<commit_message>
Regenerate all 8 role PPTX decks with Incoming PRs content
Key changes per deck:
- 05-procurement: new Incoming PRs slide, updated workflow, subtitle
  and capabilities updated to reflect early sourcing role
- 02-hod: workflow slide shows Procurement gains read-only view on
  HOD approval; Approve slide notes this explicitly
- 01-initiator: workflow annotated; track-requests step mentions
  Procurement visibility at pending_finance
- 03-finance: workflow and Who You Are slides note Procurement
  read-only access at pending_finance
- 04-md: review task step prompts checking Procurement has quotes
  ready; workflow diagram updated
- 00-all-users: workflow annotated with Procurement Incoming PRs note
- 06-stores-user, 07-admin: meta row formatting only

Co-Authored-By: Claude Sonnet 4.6 <noreply@anthropic.com>
</commit_message>
<xml_diff>
--- a/docs/user-manual/00-all-users.pptx
+++ b/docs/user-manual/00-all-users.pptx
@@ -3490,7 +3490,7 @@
                   <a:srgbClr val="8AB4D8"/>
                 </a:solidFill>
               </a:rPr>
-              <a:t>Version:  </a:t>
+              <a:t>Covers:  </a:t>
             </a:r>
             <a:r>
               <a:rPr sz="1100">
@@ -3498,7 +3498,7 @@
                   <a:srgbClr val="D0E3F2"/>
                 </a:solidFill>
               </a:rPr>
-              <a:t>1.0</a:t>
+              <a:t>Login, password change, navigation, security</a:t>
             </a:r>
           </a:p>
         </p:txBody>
@@ -3961,6 +3961,50 @@
                 <a:latin typeface="Consolas"/>
               </a:rPr>
               <a:t>  [Initiator] --&gt; pending_hod --&gt; pending_finance --&gt; pending_md* --&gt; approved</a:t>
+            </a:r>
+          </a:p>
+          <a:p>
+            <a:r>
+              <a:rPr sz="1200">
+                <a:solidFill>
+                  <a:srgbClr val="111111"/>
+                </a:solidFill>
+                <a:latin typeface="Consolas"/>
+              </a:rPr>
+              <a:t>                                        |</a:t>
+            </a:r>
+          </a:p>
+          <a:p>
+            <a:r>
+              <a:rPr sz="1200">
+                <a:solidFill>
+                  <a:srgbClr val="111111"/>
+                </a:solidFill>
+                <a:latin typeface="Consolas"/>
+              </a:rPr>
+              <a:t>                               Procurement gains read-only</a:t>
+            </a:r>
+          </a:p>
+          <a:p>
+            <a:r>
+              <a:rPr sz="1200">
+                <a:solidFill>
+                  <a:srgbClr val="111111"/>
+                </a:solidFill>
+                <a:latin typeface="Consolas"/>
+              </a:rPr>
+              <a:t>                               visibility here (Incoming PRs)</a:t>
+            </a:r>
+          </a:p>
+          <a:p>
+            <a:r>
+              <a:rPr sz="1200">
+                <a:solidFill>
+                  <a:srgbClr val="111111"/>
+                </a:solidFill>
+                <a:latin typeface="Consolas"/>
+              </a:rPr>
+              <a:t>                               and may already be sourcing quotes</a:t>
             </a:r>
           </a:p>
           <a:p>

</xml_diff>